<commit_message>
docs: use neutral ease-of-use heading in report deck
Signed-off-by: twcheong99-cloud <twcheong99@gmail.com>
</commit_message>
<xml_diff>
--- a/output/presentation-benchmark-edit/nodal-대표보고-수치반영.pptx
+++ b/output/presentation-benchmark-edit/nodal-대표보고-수치반영.pptx
@@ -2,20 +2,20 @@
 <file path=ppt/presentation.xml><?xml version="1.0" encoding="utf-8"?>
 <p:presentation xmlns:p="http://schemas.openxmlformats.org/presentationml/2006/main">
   <p:sldMasterIdLst>
-    <p:sldMasterId xmlns:r="http://schemas.openxmlformats.org/officeDocument/2006/relationships" id="2147483648" r:id="R61ada2d1ad014c86"/>
+    <p:sldMasterId xmlns:r="http://schemas.openxmlformats.org/officeDocument/2006/relationships" id="2147483648" r:id="R123e8a402dab4c3c"/>
   </p:sldMasterIdLst>
   <p:notesMasterIdLst>
-    <p:notesMasterId xmlns:r="http://schemas.openxmlformats.org/officeDocument/2006/relationships" r:id="R34b069a0ad344c90"/>
+    <p:notesMasterId xmlns:r="http://schemas.openxmlformats.org/officeDocument/2006/relationships" r:id="Ra98a83691d374603"/>
   </p:notesMasterIdLst>
   <p:sldIdLst>
-    <p:sldId xmlns:r="http://schemas.openxmlformats.org/officeDocument/2006/relationships" id="256" r:id="R80ca4cef306d4747"/>
-    <p:sldId xmlns:r="http://schemas.openxmlformats.org/officeDocument/2006/relationships" id="257" r:id="R904fd3cd4b944409"/>
-    <p:sldId xmlns:r="http://schemas.openxmlformats.org/officeDocument/2006/relationships" id="258" r:id="R286c5557d5684098"/>
-    <p:sldId xmlns:r="http://schemas.openxmlformats.org/officeDocument/2006/relationships" id="259" r:id="R4bf4ec311a184495"/>
-    <p:sldId xmlns:r="http://schemas.openxmlformats.org/officeDocument/2006/relationships" id="260" r:id="R6bba147104a3474d"/>
-    <p:sldId xmlns:r="http://schemas.openxmlformats.org/officeDocument/2006/relationships" id="261" r:id="Rfd901feaa66543fe"/>
-    <p:sldId xmlns:r="http://schemas.openxmlformats.org/officeDocument/2006/relationships" id="262" r:id="R7e2e851db7e84a0e"/>
-    <p:sldId xmlns:r="http://schemas.openxmlformats.org/officeDocument/2006/relationships" id="263" r:id="Ra4ea116ff3674834"/>
+    <p:sldId xmlns:r="http://schemas.openxmlformats.org/officeDocument/2006/relationships" id="256" r:id="R3d55684827354c3b"/>
+    <p:sldId xmlns:r="http://schemas.openxmlformats.org/officeDocument/2006/relationships" id="257" r:id="R04cdc4a2336043fe"/>
+    <p:sldId xmlns:r="http://schemas.openxmlformats.org/officeDocument/2006/relationships" id="258" r:id="R36bd013bb7504115"/>
+    <p:sldId xmlns:r="http://schemas.openxmlformats.org/officeDocument/2006/relationships" id="259" r:id="Rca454350acee4f6e"/>
+    <p:sldId xmlns:r="http://schemas.openxmlformats.org/officeDocument/2006/relationships" id="260" r:id="R135694db69134ab7"/>
+    <p:sldId xmlns:r="http://schemas.openxmlformats.org/officeDocument/2006/relationships" id="261" r:id="R283064543e664962"/>
+    <p:sldId xmlns:r="http://schemas.openxmlformats.org/officeDocument/2006/relationships" id="262" r:id="Rf7f8d15e87d54a00"/>
+    <p:sldId xmlns:r="http://schemas.openxmlformats.org/officeDocument/2006/relationships" id="263" r:id="R345859312c284383"/>
   </p:sldIdLst>
   <p:sldSz cx="12192000" cy="6858000"/>
   <p:notesSz cx="6858000" cy="9144000"/>
@@ -1175,7 +1175,7 @@
   </p:cSld>
   <p:clrMap bg1="lt1" tx1="dk1" bg2="lt2" tx2="dk2" accent1="accent1" accent2="accent2" accent3="accent3" accent4="accent4" accent5="accent5" accent6="accent6" hlink="hlink" folHlink="folHlink"/>
   <p:sldLayoutIdLst>
-    <p:sldLayoutId xmlns:r="http://schemas.openxmlformats.org/officeDocument/2006/relationships" id="2147483649" r:id="Rd1a3794a5c13492d"/>
+    <p:sldLayoutId xmlns:r="http://schemas.openxmlformats.org/officeDocument/2006/relationships" id="2147483649" r:id="R8ace0fd23c7d4f28"/>
   </p:sldLayoutIdLst>
   <p:hf sldNum="0" hdr="0" ftr="0" dt="0"/>
   <p:txStyles>
@@ -1750,7 +1750,7 @@
           <p:nvPr/>
         </p:nvPicPr>
         <p:blipFill>
-          <a:blip xmlns:r="http://schemas.openxmlformats.org/officeDocument/2006/relationships" xmlns:a="http://schemas.openxmlformats.org/drawingml/2006/main" r:embed="Rd4695dbb4cfb4048"/>
+          <a:blip xmlns:r="http://schemas.openxmlformats.org/officeDocument/2006/relationships" xmlns:a="http://schemas.openxmlformats.org/drawingml/2006/main" r:embed="R2db1f6b1cbbd45cb"/>
           <a:stretch xmlns:a="http://schemas.openxmlformats.org/drawingml/2006/main">
             <a:fillRect l="0" t="0" r="0" b="0"/>
           </a:stretch>
@@ -1972,7 +1972,7 @@
                 <a:ea typeface="Arial"/>
                 <a:cs typeface="Arial"/>
               </a:rPr>
-              <a:t>문장 하나. 그게 전부였습니다.</a:t>
+              <a:t>간단한 요청으로 이미지 생성</a:t>
             </a:r>
             <a:endParaRPr sz="3400"/>
           </a:p>
@@ -2544,7 +2544,7 @@
           <p:nvPr/>
         </p:nvPicPr>
         <p:blipFill>
-          <a:blip xmlns:r="http://schemas.openxmlformats.org/officeDocument/2006/relationships" xmlns:a="http://schemas.openxmlformats.org/drawingml/2006/main" r:embed="R4e4f46a4dd5344c7"/>
+          <a:blip xmlns:r="http://schemas.openxmlformats.org/officeDocument/2006/relationships" xmlns:a="http://schemas.openxmlformats.org/drawingml/2006/main" r:embed="Rf1edbf0c6d5a4588"/>
           <a:stretch xmlns:a="http://schemas.openxmlformats.org/drawingml/2006/main">
             <a:fillRect l="0" t="0" r="0" b="0"/>
           </a:stretch>
@@ -2568,7 +2568,7 @@
           <p:nvPr/>
         </p:nvPicPr>
         <p:blipFill>
-          <a:blip xmlns:r="http://schemas.openxmlformats.org/officeDocument/2006/relationships" xmlns:a="http://schemas.openxmlformats.org/drawingml/2006/main" r:embed="R047daf5223974d17"/>
+          <a:blip xmlns:r="http://schemas.openxmlformats.org/officeDocument/2006/relationships" xmlns:a="http://schemas.openxmlformats.org/drawingml/2006/main" r:embed="Rf70651688a9d4700"/>
           <a:stretch xmlns:a="http://schemas.openxmlformats.org/drawingml/2006/main">
             <a:fillRect l="0" t="0" r="0" b="0"/>
           </a:stretch>
@@ -2592,7 +2592,7 @@
           <p:nvPr/>
         </p:nvPicPr>
         <p:blipFill>
-          <a:blip xmlns:r="http://schemas.openxmlformats.org/officeDocument/2006/relationships" xmlns:a="http://schemas.openxmlformats.org/drawingml/2006/main" r:embed="Rf0365a4738064d6c"/>
+          <a:blip xmlns:r="http://schemas.openxmlformats.org/officeDocument/2006/relationships" xmlns:a="http://schemas.openxmlformats.org/drawingml/2006/main" r:embed="R083b05155fae47ac"/>
           <a:stretch xmlns:a="http://schemas.openxmlformats.org/drawingml/2006/main">
             <a:fillRect l="0" t="0" r="0" b="0"/>
           </a:stretch>
@@ -2616,7 +2616,7 @@
           <p:nvPr/>
         </p:nvPicPr>
         <p:blipFill>
-          <a:blip xmlns:r="http://schemas.openxmlformats.org/officeDocument/2006/relationships" xmlns:a="http://schemas.openxmlformats.org/drawingml/2006/main" r:embed="Rd2a9e1a430bb4127"/>
+          <a:blip xmlns:r="http://schemas.openxmlformats.org/officeDocument/2006/relationships" xmlns:a="http://schemas.openxmlformats.org/drawingml/2006/main" r:embed="R2d40d197e01b4132"/>
           <a:stretch xmlns:a="http://schemas.openxmlformats.org/drawingml/2006/main">
             <a:fillRect l="0" t="0" r="0" b="0"/>
           </a:stretch>
@@ -3659,7 +3659,7 @@
           <p:nvPr/>
         </p:nvPicPr>
         <p:blipFill>
-          <a:blip xmlns:r="http://schemas.openxmlformats.org/officeDocument/2006/relationships" xmlns:a="http://schemas.openxmlformats.org/drawingml/2006/main" r:embed="R83b57aac5b424472"/>
+          <a:blip xmlns:r="http://schemas.openxmlformats.org/officeDocument/2006/relationships" xmlns:a="http://schemas.openxmlformats.org/drawingml/2006/main" r:embed="R7ce3ebcae69c4b65"/>
           <a:stretch xmlns:a="http://schemas.openxmlformats.org/drawingml/2006/main">
             <a:fillRect l="0" t="0" r="0" b="0"/>
           </a:stretch>
@@ -6467,7 +6467,7 @@
           <p:nvPr/>
         </p:nvPicPr>
         <p:blipFill>
-          <a:blip xmlns:r="http://schemas.openxmlformats.org/officeDocument/2006/relationships" xmlns:a="http://schemas.openxmlformats.org/drawingml/2006/main" r:embed="R50ee9d3f45764c73"/>
+          <a:blip xmlns:r="http://schemas.openxmlformats.org/officeDocument/2006/relationships" xmlns:a="http://schemas.openxmlformats.org/drawingml/2006/main" r:embed="Racc0de353db24f34"/>
           <a:stretch xmlns:a="http://schemas.openxmlformats.org/drawingml/2006/main">
             <a:fillRect l="0" t="0" r="0" b="0"/>
           </a:stretch>
@@ -6491,7 +6491,7 @@
           <p:nvPr/>
         </p:nvPicPr>
         <p:blipFill>
-          <a:blip xmlns:r="http://schemas.openxmlformats.org/officeDocument/2006/relationships" xmlns:a="http://schemas.openxmlformats.org/drawingml/2006/main" r:embed="R6a8649f73cf64814"/>
+          <a:blip xmlns:r="http://schemas.openxmlformats.org/officeDocument/2006/relationships" xmlns:a="http://schemas.openxmlformats.org/drawingml/2006/main" r:embed="Rcb05ef38e1144762"/>
           <a:stretch xmlns:a="http://schemas.openxmlformats.org/drawingml/2006/main">
             <a:fillRect l="0" t="0" r="0" b="0"/>
           </a:stretch>
@@ -7263,7 +7263,7 @@
           <p:nvPr/>
         </p:nvPicPr>
         <p:blipFill>
-          <a:blip xmlns:r="http://schemas.openxmlformats.org/officeDocument/2006/relationships" xmlns:a="http://schemas.openxmlformats.org/drawingml/2006/main" r:embed="R7b0c9441fae045a5"/>
+          <a:blip xmlns:r="http://schemas.openxmlformats.org/officeDocument/2006/relationships" xmlns:a="http://schemas.openxmlformats.org/drawingml/2006/main" r:embed="R516f0b0a201742b3"/>
           <a:stretch xmlns:a="http://schemas.openxmlformats.org/drawingml/2006/main">
             <a:fillRect l="0" t="0" r="0" b="0"/>
           </a:stretch>
@@ -7287,7 +7287,7 @@
           <p:nvPr/>
         </p:nvPicPr>
         <p:blipFill>
-          <a:blip xmlns:r="http://schemas.openxmlformats.org/officeDocument/2006/relationships" xmlns:a="http://schemas.openxmlformats.org/drawingml/2006/main" r:embed="R07e5ea855c1c4032"/>
+          <a:blip xmlns:r="http://schemas.openxmlformats.org/officeDocument/2006/relationships" xmlns:a="http://schemas.openxmlformats.org/drawingml/2006/main" r:embed="Refebc2adb9fd4eb6"/>
           <a:stretch xmlns:a="http://schemas.openxmlformats.org/drawingml/2006/main">
             <a:fillRect l="0" t="0" r="0" b="0"/>
           </a:stretch>
@@ -7311,7 +7311,7 @@
           <p:nvPr/>
         </p:nvPicPr>
         <p:blipFill>
-          <a:blip xmlns:r="http://schemas.openxmlformats.org/officeDocument/2006/relationships" xmlns:a="http://schemas.openxmlformats.org/drawingml/2006/main" r:embed="R46c007cc86a64842"/>
+          <a:blip xmlns:r="http://schemas.openxmlformats.org/officeDocument/2006/relationships" xmlns:a="http://schemas.openxmlformats.org/drawingml/2006/main" r:embed="R4c0d62108fd549de"/>
           <a:stretch xmlns:a="http://schemas.openxmlformats.org/drawingml/2006/main">
             <a:fillRect l="0" t="0" r="0" b="0"/>
           </a:stretch>
@@ -7335,7 +7335,7 @@
           <p:nvPr/>
         </p:nvPicPr>
         <p:blipFill>
-          <a:blip xmlns:r="http://schemas.openxmlformats.org/officeDocument/2006/relationships" xmlns:a="http://schemas.openxmlformats.org/drawingml/2006/main" r:embed="R7bd4f7347ba44a13"/>
+          <a:blip xmlns:r="http://schemas.openxmlformats.org/officeDocument/2006/relationships" xmlns:a="http://schemas.openxmlformats.org/drawingml/2006/main" r:embed="Rb84ed40f13304036"/>
           <a:stretch xmlns:a="http://schemas.openxmlformats.org/drawingml/2006/main">
             <a:fillRect l="0" t="0" r="0" b="0"/>
           </a:stretch>

</xml_diff>